<commit_message>
updated the poster template
</commit_message>
<xml_diff>
--- a/_site/assets/slides/event/FacultyHack25_Poster_Template.pptx
+++ b/_site/assets/slides/event/FacultyHack25_Poster_Template.pptx
@@ -256,8 +256,11 @@
     </a:lvl9pPr>
   </p:defaultTextStyle>
   <p:extLst>
+    <p:ext uri="{EFAFB233-063F-42B5-8137-9DF3F51BA10A}">
+      <p15:sldGuideLst xmlns:p15="http://schemas.microsoft.com/office/powerpoint/2012/main"/>
+    </p:ext>
     <p:ext uri="GoogleSlidesCustomDataVersion2">
-      <go:slidesCustomData xmlns:go="http://customooxmlschemas.google.com/" xmlns:ahyp="http://schemas.microsoft.com/office/drawing/2018/hyperlinkcolor" xmlns:p15="http://schemas.microsoft.com/office/powerpoint/2012/main" xmlns:p14="http://schemas.microsoft.com/office/powerpoint/2010/main" xmlns:com="http://schemas.openxmlformats.org/drawingml/2006/compatibility" xmlns:pvml="urn:schemas-microsoft-com:office:powerpoint" xmlns:v="urn:schemas-microsoft-com:vml" xmlns:o="urn:schemas-microsoft-com:office:office" xmlns:dgm="http://schemas.openxmlformats.org/drawingml/2006/diagram" xmlns:c="http://schemas.openxmlformats.org/drawingml/2006/chart" xmlns:mv="urn:schemas-microsoft-com:mac:vml" xmlns:mc="http://schemas.openxmlformats.org/markup-compatibility/2006" xmlns="" r:id="rId10" roundtripDataSignature="AMtx7mj2lCnrPOAb5FD/7LHIg2ZKJEG5Rw=="/>
+      <go:slidesCustomData xmlns="" xmlns:mc="http://schemas.openxmlformats.org/markup-compatibility/2006" xmlns:mv="urn:schemas-microsoft-com:mac:vml" xmlns:c="http://schemas.openxmlformats.org/drawingml/2006/chart" xmlns:dgm="http://schemas.openxmlformats.org/drawingml/2006/diagram" xmlns:o="urn:schemas-microsoft-com:office:office" xmlns:v="urn:schemas-microsoft-com:vml" xmlns:pvml="urn:schemas-microsoft-com:office:powerpoint" xmlns:com="http://schemas.openxmlformats.org/drawingml/2006/compatibility" xmlns:p14="http://schemas.microsoft.com/office/powerpoint/2010/main" xmlns:p15="http://schemas.microsoft.com/office/powerpoint/2012/main" xmlns:ahyp="http://schemas.microsoft.com/office/drawing/2018/hyperlinkcolor" xmlns:go="http://customooxmlschemas.google.com/" r:id="rId10" roundtripDataSignature="AMtx7mj2lCnrPOAb5FD/7LHIg2ZKJEG5Rw=="/>
     </p:ext>
   </p:extLst>
 </p:presentation>
@@ -1605,357 +1608,6 @@
           </a:p>
         </p:txBody>
       </p:sp>
-      <p:sp>
-        <p:nvSpPr>
-          <p:cNvPr id="3" name="TextBox 2">
-            <a:extLst>
-              <a:ext uri="{FF2B5EF4-FFF2-40B4-BE49-F238E27FC236}">
-                <a16:creationId xmlns:a16="http://schemas.microsoft.com/office/drawing/2014/main" id="{EF123D09-D505-2D72-9FDF-F22657DAD764}"/>
-              </a:ext>
-            </a:extLst>
-          </p:cNvPr>
-          <p:cNvSpPr txBox="1"/>
-          <p:nvPr userDrawn="1"/>
-        </p:nvSpPr>
-        <p:spPr>
-          <a:xfrm>
-            <a:off x="353910" y="2686884"/>
-            <a:ext cx="12824210" cy="646331"/>
-          </a:xfrm>
-          <a:prstGeom prst="rect">
-            <a:avLst/>
-          </a:prstGeom>
-          <a:solidFill>
-            <a:srgbClr val="005698"/>
-          </a:solidFill>
-        </p:spPr>
-        <p:txBody>
-          <a:bodyPr wrap="square" lIns="457200" anchor="ctr">
-            <a:spAutoFit/>
-          </a:bodyPr>
-          <a:lstStyle/>
-          <a:p>
-            <a:pPr>
-              <a:defRPr sz="3600" b="1">
-                <a:solidFill>
-                  <a:srgbClr val="004C99"/>
-                </a:solidFill>
-              </a:defRPr>
-            </a:pPr>
-            <a:r>
-              <a:rPr lang="en-US" dirty="0">
-                <a:solidFill>
-                  <a:srgbClr val="F7E8C9"/>
-                </a:solidFill>
-              </a:rPr>
-              <a:t>Introduction</a:t>
-            </a:r>
-            <a:endParaRPr dirty="0">
-              <a:solidFill>
-                <a:srgbClr val="F7E8C9"/>
-              </a:solidFill>
-            </a:endParaRPr>
-          </a:p>
-        </p:txBody>
-      </p:sp>
-      <p:sp>
-        <p:nvSpPr>
-          <p:cNvPr id="4" name="TextBox 3">
-            <a:extLst>
-              <a:ext uri="{FF2B5EF4-FFF2-40B4-BE49-F238E27FC236}">
-                <a16:creationId xmlns:a16="http://schemas.microsoft.com/office/drawing/2014/main" id="{B01DE082-BBA3-F7F3-B09A-8EC0F313C953}"/>
-              </a:ext>
-            </a:extLst>
-          </p:cNvPr>
-          <p:cNvSpPr txBox="1"/>
-          <p:nvPr userDrawn="1"/>
-        </p:nvSpPr>
-        <p:spPr>
-          <a:xfrm>
-            <a:off x="1353365" y="15028144"/>
-            <a:ext cx="11824752" cy="646331"/>
-          </a:xfrm>
-          <a:prstGeom prst="rect">
-            <a:avLst/>
-          </a:prstGeom>
-          <a:solidFill>
-            <a:schemeClr val="bg1"/>
-          </a:solidFill>
-          <a:ln w="12700">
-            <a:solidFill>
-              <a:srgbClr val="005698"/>
-            </a:solidFill>
-          </a:ln>
-        </p:spPr>
-        <p:txBody>
-          <a:bodyPr wrap="square" lIns="457200" anchor="ctr">
-            <a:spAutoFit/>
-          </a:bodyPr>
-          <a:lstStyle/>
-          <a:p>
-            <a:pPr>
-              <a:defRPr sz="3600" b="1">
-                <a:solidFill>
-                  <a:srgbClr val="004C99"/>
-                </a:solidFill>
-              </a:defRPr>
-            </a:pPr>
-            <a:r>
-              <a:rPr lang="en-US" dirty="0">
-                <a:solidFill>
-                  <a:srgbClr val="005698"/>
-                </a:solidFill>
-              </a:rPr>
-              <a:t>Goals</a:t>
-            </a:r>
-            <a:endParaRPr dirty="0">
-              <a:solidFill>
-                <a:srgbClr val="005698"/>
-              </a:solidFill>
-            </a:endParaRPr>
-          </a:p>
-        </p:txBody>
-      </p:sp>
-      <p:sp>
-        <p:nvSpPr>
-          <p:cNvPr id="5" name="TextBox 4">
-            <a:extLst>
-              <a:ext uri="{FF2B5EF4-FFF2-40B4-BE49-F238E27FC236}">
-                <a16:creationId xmlns:a16="http://schemas.microsoft.com/office/drawing/2014/main" id="{DEF8380A-832F-A6B6-C1F9-9B5CD9ACF8AD}"/>
-              </a:ext>
-            </a:extLst>
-          </p:cNvPr>
-          <p:cNvSpPr txBox="1"/>
-          <p:nvPr userDrawn="1"/>
-        </p:nvSpPr>
-        <p:spPr>
-          <a:xfrm>
-            <a:off x="353909" y="24341062"/>
-            <a:ext cx="12824209" cy="646331"/>
-          </a:xfrm>
-          <a:prstGeom prst="rect">
-            <a:avLst/>
-          </a:prstGeom>
-          <a:solidFill>
-            <a:srgbClr val="005698"/>
-          </a:solidFill>
-        </p:spPr>
-        <p:txBody>
-          <a:bodyPr wrap="square" lIns="457200" anchor="ctr">
-            <a:spAutoFit/>
-          </a:bodyPr>
-          <a:lstStyle/>
-          <a:p>
-            <a:pPr>
-              <a:defRPr sz="3600" b="1">
-                <a:solidFill>
-                  <a:srgbClr val="004C99"/>
-                </a:solidFill>
-              </a:defRPr>
-            </a:pPr>
-            <a:r>
-              <a:rPr dirty="0">
-                <a:solidFill>
-                  <a:srgbClr val="F7E8C9"/>
-                </a:solidFill>
-              </a:rPr>
-              <a:t>Initial Course Syllabus</a:t>
-            </a:r>
-          </a:p>
-        </p:txBody>
-      </p:sp>
-      <p:sp>
-        <p:nvSpPr>
-          <p:cNvPr id="11" name="TextBox 10">
-            <a:extLst>
-              <a:ext uri="{FF2B5EF4-FFF2-40B4-BE49-F238E27FC236}">
-                <a16:creationId xmlns:a16="http://schemas.microsoft.com/office/drawing/2014/main" id="{22A23F01-9E02-4446-6C13-799C5356DEAA}"/>
-              </a:ext>
-            </a:extLst>
-          </p:cNvPr>
-          <p:cNvSpPr txBox="1"/>
-          <p:nvPr userDrawn="1"/>
-        </p:nvSpPr>
-        <p:spPr>
-          <a:xfrm>
-            <a:off x="14253881" y="2686884"/>
-            <a:ext cx="12824210" cy="646331"/>
-          </a:xfrm>
-          <a:prstGeom prst="rect">
-            <a:avLst/>
-          </a:prstGeom>
-          <a:solidFill>
-            <a:srgbClr val="005698"/>
-          </a:solidFill>
-        </p:spPr>
-        <p:txBody>
-          <a:bodyPr wrap="square" lIns="457200" anchor="ctr">
-            <a:spAutoFit/>
-          </a:bodyPr>
-          <a:lstStyle/>
-          <a:p>
-            <a:pPr>
-              <a:defRPr sz="3600" b="1">
-                <a:solidFill>
-                  <a:srgbClr val="004C99"/>
-                </a:solidFill>
-              </a:defRPr>
-            </a:pPr>
-            <a:r>
-              <a:rPr dirty="0">
-                <a:solidFill>
-                  <a:srgbClr val="F7E8C9"/>
-                </a:solidFill>
-              </a:rPr>
-              <a:t>Modified Course Syllabus</a:t>
-            </a:r>
-          </a:p>
-        </p:txBody>
-      </p:sp>
-      <p:sp>
-        <p:nvSpPr>
-          <p:cNvPr id="12" name="TextBox 11">
-            <a:extLst>
-              <a:ext uri="{FF2B5EF4-FFF2-40B4-BE49-F238E27FC236}">
-                <a16:creationId xmlns:a16="http://schemas.microsoft.com/office/drawing/2014/main" id="{15C29343-6EDC-AE68-B797-41EF96CDE4F1}"/>
-              </a:ext>
-            </a:extLst>
-          </p:cNvPr>
-          <p:cNvSpPr txBox="1"/>
-          <p:nvPr userDrawn="1"/>
-        </p:nvSpPr>
-        <p:spPr>
-          <a:xfrm>
-            <a:off x="14253880" y="13701905"/>
-            <a:ext cx="12824210" cy="646331"/>
-          </a:xfrm>
-          <a:prstGeom prst="rect">
-            <a:avLst/>
-          </a:prstGeom>
-          <a:solidFill>
-            <a:srgbClr val="005698"/>
-          </a:solidFill>
-        </p:spPr>
-        <p:txBody>
-          <a:bodyPr wrap="square" lIns="457200" anchor="ctr">
-            <a:spAutoFit/>
-          </a:bodyPr>
-          <a:lstStyle/>
-          <a:p>
-            <a:pPr>
-              <a:defRPr sz="3600" b="1">
-                <a:solidFill>
-                  <a:srgbClr val="004C99"/>
-                </a:solidFill>
-              </a:defRPr>
-            </a:pPr>
-            <a:r>
-              <a:rPr dirty="0">
-                <a:solidFill>
-                  <a:srgbClr val="F7E8C9"/>
-                </a:solidFill>
-              </a:rPr>
-              <a:t>Science Gateways Resources Used</a:t>
-            </a:r>
-          </a:p>
-        </p:txBody>
-      </p:sp>
-      <p:sp>
-        <p:nvSpPr>
-          <p:cNvPr id="13" name="TextBox 12">
-            <a:extLst>
-              <a:ext uri="{FF2B5EF4-FFF2-40B4-BE49-F238E27FC236}">
-                <a16:creationId xmlns:a16="http://schemas.microsoft.com/office/drawing/2014/main" id="{2880188C-D200-BCF3-EE90-1777C6DC0C02}"/>
-              </a:ext>
-            </a:extLst>
-          </p:cNvPr>
-          <p:cNvSpPr txBox="1"/>
-          <p:nvPr userDrawn="1"/>
-        </p:nvSpPr>
-        <p:spPr>
-          <a:xfrm>
-            <a:off x="14253880" y="18235354"/>
-            <a:ext cx="12824210" cy="646331"/>
-          </a:xfrm>
-          <a:prstGeom prst="rect">
-            <a:avLst/>
-          </a:prstGeom>
-          <a:solidFill>
-            <a:srgbClr val="005698"/>
-          </a:solidFill>
-        </p:spPr>
-        <p:txBody>
-          <a:bodyPr wrap="square" lIns="457200" anchor="ctr">
-            <a:spAutoFit/>
-          </a:bodyPr>
-          <a:lstStyle/>
-          <a:p>
-            <a:pPr>
-              <a:defRPr sz="3600" b="1">
-                <a:solidFill>
-                  <a:srgbClr val="004C99"/>
-                </a:solidFill>
-              </a:defRPr>
-            </a:pPr>
-            <a:r>
-              <a:rPr lang="en-US" dirty="0">
-                <a:solidFill>
-                  <a:srgbClr val="F7E8C9"/>
-                </a:solidFill>
-              </a:rPr>
-              <a:t>Expansions</a:t>
-            </a:r>
-          </a:p>
-        </p:txBody>
-      </p:sp>
-      <p:sp>
-        <p:nvSpPr>
-          <p:cNvPr id="14" name="TextBox 13">
-            <a:extLst>
-              <a:ext uri="{FF2B5EF4-FFF2-40B4-BE49-F238E27FC236}">
-                <a16:creationId xmlns:a16="http://schemas.microsoft.com/office/drawing/2014/main" id="{F66738B9-6F90-2871-3A72-7C14C05BA3ED}"/>
-              </a:ext>
-            </a:extLst>
-          </p:cNvPr>
-          <p:cNvSpPr txBox="1"/>
-          <p:nvPr userDrawn="1"/>
-        </p:nvSpPr>
-        <p:spPr>
-          <a:xfrm>
-            <a:off x="14253880" y="26009590"/>
-            <a:ext cx="12824210" cy="646331"/>
-          </a:xfrm>
-          <a:prstGeom prst="rect">
-            <a:avLst/>
-          </a:prstGeom>
-          <a:solidFill>
-            <a:srgbClr val="005698"/>
-          </a:solidFill>
-        </p:spPr>
-        <p:txBody>
-          <a:bodyPr wrap="square" lIns="457200" anchor="ctr">
-            <a:spAutoFit/>
-          </a:bodyPr>
-          <a:lstStyle/>
-          <a:p>
-            <a:pPr>
-              <a:defRPr sz="3600" b="1">
-                <a:solidFill>
-                  <a:srgbClr val="004C99"/>
-                </a:solidFill>
-              </a:defRPr>
-            </a:pPr>
-            <a:r>
-              <a:rPr dirty="0">
-                <a:solidFill>
-                  <a:srgbClr val="F7E8C9"/>
-                </a:solidFill>
-              </a:rPr>
-              <a:t>References</a:t>
-            </a:r>
-          </a:p>
-        </p:txBody>
-      </p:sp>
       <p:pic>
         <p:nvPicPr>
           <p:cNvPr id="15" name="Picture 14" descr="A close-up of a paper&#10;&#10;AI-generated content may be incorrect.">
@@ -2383,64 +2035,6 @@
           </a:prstGeom>
         </p:spPr>
       </p:pic>
-      <p:sp>
-        <p:nvSpPr>
-          <p:cNvPr id="26" name="TextBox 25">
-            <a:extLst>
-              <a:ext uri="{FF2B5EF4-FFF2-40B4-BE49-F238E27FC236}">
-                <a16:creationId xmlns:a16="http://schemas.microsoft.com/office/drawing/2014/main" id="{066A6139-67D7-4938-3837-A60ABC2FA6EB}"/>
-              </a:ext>
-            </a:extLst>
-          </p:cNvPr>
-          <p:cNvSpPr txBox="1"/>
-          <p:nvPr userDrawn="1"/>
-        </p:nvSpPr>
-        <p:spPr>
-          <a:xfrm>
-            <a:off x="1353365" y="8411907"/>
-            <a:ext cx="11824751" cy="646331"/>
-          </a:xfrm>
-          <a:prstGeom prst="rect">
-            <a:avLst/>
-          </a:prstGeom>
-          <a:solidFill>
-            <a:schemeClr val="bg1"/>
-          </a:solidFill>
-          <a:ln w="12700">
-            <a:solidFill>
-              <a:srgbClr val="005698"/>
-            </a:solidFill>
-          </a:ln>
-        </p:spPr>
-        <p:txBody>
-          <a:bodyPr wrap="square" lIns="457200" anchor="ctr">
-            <a:spAutoFit/>
-          </a:bodyPr>
-          <a:lstStyle/>
-          <a:p>
-            <a:pPr>
-              <a:defRPr sz="3600" b="1">
-                <a:solidFill>
-                  <a:srgbClr val="004C99"/>
-                </a:solidFill>
-              </a:defRPr>
-            </a:pPr>
-            <a:r>
-              <a:rPr lang="en-US" dirty="0">
-                <a:solidFill>
-                  <a:srgbClr val="005698"/>
-                </a:solidFill>
-              </a:rPr>
-              <a:t>Target Course Description</a:t>
-            </a:r>
-            <a:endParaRPr dirty="0">
-              <a:solidFill>
-                <a:srgbClr val="005698"/>
-              </a:solidFill>
-            </a:endParaRPr>
-          </a:p>
-        </p:txBody>
-      </p:sp>
       <p:pic>
         <p:nvPicPr>
           <p:cNvPr id="27" name="Graphic 26">
@@ -2544,112 +2138,6 @@
               </a:rPr>
               <a:t>under award number 2231406.</a:t>
             </a:r>
-          </a:p>
-        </p:txBody>
-      </p:sp>
-      <p:sp>
-        <p:nvSpPr>
-          <p:cNvPr id="30" name="TextBox 29">
-            <a:extLst>
-              <a:ext uri="{FF2B5EF4-FFF2-40B4-BE49-F238E27FC236}">
-                <a16:creationId xmlns:a16="http://schemas.microsoft.com/office/drawing/2014/main" id="{DA0DA89B-06AD-C36A-7509-CBF5BFE975E6}"/>
-              </a:ext>
-            </a:extLst>
-          </p:cNvPr>
-          <p:cNvSpPr txBox="1"/>
-          <p:nvPr userDrawn="1"/>
-        </p:nvSpPr>
-        <p:spPr>
-          <a:xfrm>
-            <a:off x="14253880" y="30278083"/>
-            <a:ext cx="12824210" cy="646331"/>
-          </a:xfrm>
-          <a:prstGeom prst="rect">
-            <a:avLst/>
-          </a:prstGeom>
-          <a:solidFill>
-            <a:srgbClr val="005698"/>
-          </a:solidFill>
-        </p:spPr>
-        <p:txBody>
-          <a:bodyPr wrap="square" lIns="457200" anchor="ctr">
-            <a:spAutoFit/>
-          </a:bodyPr>
-          <a:lstStyle/>
-          <a:p>
-            <a:pPr>
-              <a:defRPr sz="3600" b="1">
-                <a:solidFill>
-                  <a:srgbClr val="004C99"/>
-                </a:solidFill>
-              </a:defRPr>
-            </a:pPr>
-            <a:r>
-              <a:rPr lang="en-US" dirty="0">
-                <a:solidFill>
-                  <a:srgbClr val="F7E8C9"/>
-                </a:solidFill>
-              </a:rPr>
-              <a:t>Authors</a:t>
-            </a:r>
-            <a:endParaRPr dirty="0">
-              <a:solidFill>
-                <a:srgbClr val="F7E8C9"/>
-              </a:solidFill>
-            </a:endParaRPr>
-          </a:p>
-        </p:txBody>
-      </p:sp>
-      <p:sp>
-        <p:nvSpPr>
-          <p:cNvPr id="31" name="TextBox 30">
-            <a:extLst>
-              <a:ext uri="{FF2B5EF4-FFF2-40B4-BE49-F238E27FC236}">
-                <a16:creationId xmlns:a16="http://schemas.microsoft.com/office/drawing/2014/main" id="{A70FDB91-5DC8-9B81-17FA-D23A47E9A80E}"/>
-              </a:ext>
-            </a:extLst>
-          </p:cNvPr>
-          <p:cNvSpPr txBox="1"/>
-          <p:nvPr userDrawn="1"/>
-        </p:nvSpPr>
-        <p:spPr>
-          <a:xfrm>
-            <a:off x="14253880" y="9657060"/>
-            <a:ext cx="12824210" cy="646331"/>
-          </a:xfrm>
-          <a:prstGeom prst="rect">
-            <a:avLst/>
-          </a:prstGeom>
-          <a:solidFill>
-            <a:srgbClr val="005698"/>
-          </a:solidFill>
-        </p:spPr>
-        <p:txBody>
-          <a:bodyPr wrap="square" lIns="457200" anchor="ctr">
-            <a:spAutoFit/>
-          </a:bodyPr>
-          <a:lstStyle/>
-          <a:p>
-            <a:pPr>
-              <a:defRPr sz="3600" b="1">
-                <a:solidFill>
-                  <a:srgbClr val="004C99"/>
-                </a:solidFill>
-              </a:defRPr>
-            </a:pPr>
-            <a:r>
-              <a:rPr lang="en-US" dirty="0">
-                <a:solidFill>
-                  <a:srgbClr val="F7E8C9"/>
-                </a:solidFill>
-              </a:rPr>
-              <a:t>Mentor Suggestions</a:t>
-            </a:r>
-            <a:endParaRPr dirty="0">
-              <a:solidFill>
-                <a:srgbClr val="F7E8C9"/>
-              </a:solidFill>
-            </a:endParaRPr>
           </a:p>
         </p:txBody>
       </p:sp>
@@ -3418,315 +2906,6 @@
           </a:p>
         </p:txBody>
       </p:sp>
-      <p:sp>
-        <p:nvSpPr>
-          <p:cNvPr id="3" name="TextBox 2"/>
-          <p:cNvSpPr txBox="1"/>
-          <p:nvPr/>
-        </p:nvSpPr>
-        <p:spPr>
-          <a:xfrm>
-            <a:off x="353910" y="2686884"/>
-            <a:ext cx="12824210" cy="646331"/>
-          </a:xfrm>
-          <a:prstGeom prst="rect">
-            <a:avLst/>
-          </a:prstGeom>
-          <a:solidFill>
-            <a:srgbClr val="005698"/>
-          </a:solidFill>
-        </p:spPr>
-        <p:txBody>
-          <a:bodyPr wrap="square" lIns="457200" anchor="ctr">
-            <a:spAutoFit/>
-          </a:bodyPr>
-          <a:lstStyle/>
-          <a:p>
-            <a:pPr>
-              <a:defRPr sz="3600" b="1">
-                <a:solidFill>
-                  <a:srgbClr val="004C99"/>
-                </a:solidFill>
-              </a:defRPr>
-            </a:pPr>
-            <a:r>
-              <a:rPr lang="en-US" dirty="0">
-                <a:solidFill>
-                  <a:srgbClr val="F7E8C9"/>
-                </a:solidFill>
-              </a:rPr>
-              <a:t>Introduction</a:t>
-            </a:r>
-            <a:endParaRPr dirty="0">
-              <a:solidFill>
-                <a:srgbClr val="F7E8C9"/>
-              </a:solidFill>
-            </a:endParaRPr>
-          </a:p>
-        </p:txBody>
-      </p:sp>
-      <p:sp>
-        <p:nvSpPr>
-          <p:cNvPr id="4" name="TextBox 3"/>
-          <p:cNvSpPr txBox="1"/>
-          <p:nvPr/>
-        </p:nvSpPr>
-        <p:spPr>
-          <a:xfrm>
-            <a:off x="1353365" y="15028144"/>
-            <a:ext cx="11824752" cy="646331"/>
-          </a:xfrm>
-          <a:prstGeom prst="rect">
-            <a:avLst/>
-          </a:prstGeom>
-          <a:solidFill>
-            <a:schemeClr val="bg1"/>
-          </a:solidFill>
-          <a:ln w="12700">
-            <a:solidFill>
-              <a:srgbClr val="005698"/>
-            </a:solidFill>
-          </a:ln>
-        </p:spPr>
-        <p:txBody>
-          <a:bodyPr wrap="square" lIns="457200" anchor="ctr">
-            <a:spAutoFit/>
-          </a:bodyPr>
-          <a:lstStyle/>
-          <a:p>
-            <a:pPr>
-              <a:defRPr sz="3600" b="1">
-                <a:solidFill>
-                  <a:srgbClr val="004C99"/>
-                </a:solidFill>
-              </a:defRPr>
-            </a:pPr>
-            <a:r>
-              <a:rPr lang="en-US" dirty="0">
-                <a:solidFill>
-                  <a:srgbClr val="005698"/>
-                </a:solidFill>
-              </a:rPr>
-              <a:t>Goals</a:t>
-            </a:r>
-            <a:endParaRPr dirty="0">
-              <a:solidFill>
-                <a:srgbClr val="005698"/>
-              </a:solidFill>
-            </a:endParaRPr>
-          </a:p>
-        </p:txBody>
-      </p:sp>
-      <p:sp>
-        <p:nvSpPr>
-          <p:cNvPr id="5" name="TextBox 4"/>
-          <p:cNvSpPr txBox="1"/>
-          <p:nvPr/>
-        </p:nvSpPr>
-        <p:spPr>
-          <a:xfrm>
-            <a:off x="353909" y="24341062"/>
-            <a:ext cx="12824209" cy="646331"/>
-          </a:xfrm>
-          <a:prstGeom prst="rect">
-            <a:avLst/>
-          </a:prstGeom>
-          <a:solidFill>
-            <a:srgbClr val="005698"/>
-          </a:solidFill>
-        </p:spPr>
-        <p:txBody>
-          <a:bodyPr wrap="square" lIns="457200" anchor="ctr">
-            <a:spAutoFit/>
-          </a:bodyPr>
-          <a:lstStyle/>
-          <a:p>
-            <a:pPr>
-              <a:defRPr sz="3600" b="1">
-                <a:solidFill>
-                  <a:srgbClr val="004C99"/>
-                </a:solidFill>
-              </a:defRPr>
-            </a:pPr>
-            <a:r>
-              <a:rPr dirty="0">
-                <a:solidFill>
-                  <a:srgbClr val="F7E8C9"/>
-                </a:solidFill>
-              </a:rPr>
-              <a:t>Initial Course Syllabus</a:t>
-            </a:r>
-          </a:p>
-        </p:txBody>
-      </p:sp>
-      <p:sp>
-        <p:nvSpPr>
-          <p:cNvPr id="6" name="TextBox 5"/>
-          <p:cNvSpPr txBox="1"/>
-          <p:nvPr/>
-        </p:nvSpPr>
-        <p:spPr>
-          <a:xfrm>
-            <a:off x="14253881" y="2686884"/>
-            <a:ext cx="12824210" cy="646331"/>
-          </a:xfrm>
-          <a:prstGeom prst="rect">
-            <a:avLst/>
-          </a:prstGeom>
-          <a:solidFill>
-            <a:srgbClr val="005698"/>
-          </a:solidFill>
-        </p:spPr>
-        <p:txBody>
-          <a:bodyPr wrap="square" lIns="457200" anchor="ctr">
-            <a:spAutoFit/>
-          </a:bodyPr>
-          <a:lstStyle/>
-          <a:p>
-            <a:pPr>
-              <a:defRPr sz="3600" b="1">
-                <a:solidFill>
-                  <a:srgbClr val="004C99"/>
-                </a:solidFill>
-              </a:defRPr>
-            </a:pPr>
-            <a:r>
-              <a:rPr dirty="0">
-                <a:solidFill>
-                  <a:srgbClr val="F7E8C9"/>
-                </a:solidFill>
-              </a:rPr>
-              <a:t>Modified Course Syllabus</a:t>
-            </a:r>
-          </a:p>
-        </p:txBody>
-      </p:sp>
-      <p:sp>
-        <p:nvSpPr>
-          <p:cNvPr id="7" name="TextBox 6"/>
-          <p:cNvSpPr txBox="1"/>
-          <p:nvPr/>
-        </p:nvSpPr>
-        <p:spPr>
-          <a:xfrm>
-            <a:off x="14253880" y="13701905"/>
-            <a:ext cx="12824210" cy="646331"/>
-          </a:xfrm>
-          <a:prstGeom prst="rect">
-            <a:avLst/>
-          </a:prstGeom>
-          <a:solidFill>
-            <a:srgbClr val="005698"/>
-          </a:solidFill>
-        </p:spPr>
-        <p:txBody>
-          <a:bodyPr wrap="square" lIns="457200" anchor="ctr">
-            <a:spAutoFit/>
-          </a:bodyPr>
-          <a:lstStyle/>
-          <a:p>
-            <a:pPr>
-              <a:defRPr sz="3600" b="1">
-                <a:solidFill>
-                  <a:srgbClr val="004C99"/>
-                </a:solidFill>
-              </a:defRPr>
-            </a:pPr>
-            <a:r>
-              <a:rPr dirty="0">
-                <a:solidFill>
-                  <a:srgbClr val="F7E8C9"/>
-                </a:solidFill>
-              </a:rPr>
-              <a:t>Science Gateways Resources Used</a:t>
-            </a:r>
-          </a:p>
-        </p:txBody>
-      </p:sp>
-      <p:sp>
-        <p:nvSpPr>
-          <p:cNvPr id="8" name="TextBox 7"/>
-          <p:cNvSpPr txBox="1"/>
-          <p:nvPr/>
-        </p:nvSpPr>
-        <p:spPr>
-          <a:xfrm>
-            <a:off x="14253880" y="18235354"/>
-            <a:ext cx="12824210" cy="646331"/>
-          </a:xfrm>
-          <a:prstGeom prst="rect">
-            <a:avLst/>
-          </a:prstGeom>
-          <a:solidFill>
-            <a:srgbClr val="005698"/>
-          </a:solidFill>
-        </p:spPr>
-        <p:txBody>
-          <a:bodyPr wrap="square" lIns="457200" anchor="ctr">
-            <a:spAutoFit/>
-          </a:bodyPr>
-          <a:lstStyle/>
-          <a:p>
-            <a:pPr>
-              <a:defRPr sz="3600" b="1">
-                <a:solidFill>
-                  <a:srgbClr val="004C99"/>
-                </a:solidFill>
-              </a:defRPr>
-            </a:pPr>
-            <a:r>
-              <a:rPr lang="en-US" dirty="0">
-                <a:solidFill>
-                  <a:srgbClr val="F7E8C9"/>
-                </a:solidFill>
-              </a:rPr>
-              <a:t>Expansions</a:t>
-            </a:r>
-          </a:p>
-        </p:txBody>
-      </p:sp>
-      <p:sp>
-        <p:nvSpPr>
-          <p:cNvPr id="9" name="TextBox 8"/>
-          <p:cNvSpPr txBox="1"/>
-          <p:nvPr/>
-        </p:nvSpPr>
-        <p:spPr>
-          <a:xfrm>
-            <a:off x="14253880" y="26009590"/>
-            <a:ext cx="12824210" cy="646331"/>
-          </a:xfrm>
-          <a:prstGeom prst="rect">
-            <a:avLst/>
-          </a:prstGeom>
-          <a:solidFill>
-            <a:srgbClr val="005698"/>
-          </a:solidFill>
-        </p:spPr>
-        <p:txBody>
-          <a:bodyPr wrap="square" lIns="457200" anchor="ctr">
-            <a:spAutoFit/>
-          </a:bodyPr>
-          <a:lstStyle/>
-          <a:p>
-            <a:pPr>
-              <a:defRPr sz="3600" b="1">
-                <a:solidFill>
-                  <a:srgbClr val="004C99"/>
-                </a:solidFill>
-              </a:defRPr>
-            </a:pPr>
-            <a:r>
-              <a:rPr dirty="0">
-                <a:solidFill>
-                  <a:srgbClr val="F7E8C9"/>
-                </a:solidFill>
-              </a:rPr>
-              <a:t>References</a:t>
-            </a:r>
-          </a:p>
-        </p:txBody>
-      </p:sp>
       <p:pic>
         <p:nvPicPr>
           <p:cNvPr id="18" name="Picture 17" descr="A close-up of a paper&#10;&#10;AI-generated content may be incorrect.">
@@ -4194,64 +3373,6 @@
           </a:prstGeom>
         </p:spPr>
       </p:pic>
-      <p:sp>
-        <p:nvSpPr>
-          <p:cNvPr id="29" name="TextBox 28">
-            <a:extLst>
-              <a:ext uri="{FF2B5EF4-FFF2-40B4-BE49-F238E27FC236}">
-                <a16:creationId xmlns:a16="http://schemas.microsoft.com/office/drawing/2014/main" id="{C7EE9000-6B36-8114-32C8-21316914DAF9}"/>
-              </a:ext>
-            </a:extLst>
-          </p:cNvPr>
-          <p:cNvSpPr txBox="1"/>
-          <p:nvPr/>
-        </p:nvSpPr>
-        <p:spPr>
-          <a:xfrm>
-            <a:off x="1353365" y="8411907"/>
-            <a:ext cx="11824751" cy="646331"/>
-          </a:xfrm>
-          <a:prstGeom prst="rect">
-            <a:avLst/>
-          </a:prstGeom>
-          <a:solidFill>
-            <a:schemeClr val="bg1"/>
-          </a:solidFill>
-          <a:ln w="12700">
-            <a:solidFill>
-              <a:srgbClr val="005698"/>
-            </a:solidFill>
-          </a:ln>
-        </p:spPr>
-        <p:txBody>
-          <a:bodyPr wrap="square" lIns="457200" anchor="ctr">
-            <a:spAutoFit/>
-          </a:bodyPr>
-          <a:lstStyle/>
-          <a:p>
-            <a:pPr>
-              <a:defRPr sz="3600" b="1">
-                <a:solidFill>
-                  <a:srgbClr val="004C99"/>
-                </a:solidFill>
-              </a:defRPr>
-            </a:pPr>
-            <a:r>
-              <a:rPr lang="en-US" dirty="0">
-                <a:solidFill>
-                  <a:srgbClr val="005698"/>
-                </a:solidFill>
-              </a:rPr>
-              <a:t>Target Course Description</a:t>
-            </a:r>
-            <a:endParaRPr dirty="0">
-              <a:solidFill>
-                <a:srgbClr val="005698"/>
-              </a:solidFill>
-            </a:endParaRPr>
-          </a:p>
-        </p:txBody>
-      </p:sp>
       <p:pic>
         <p:nvPicPr>
           <p:cNvPr id="35" name="Graphic 34">
@@ -5073,112 +4194,6 @@
       </p:graphicFrame>
       <p:sp>
         <p:nvSpPr>
-          <p:cNvPr id="44" name="TextBox 43">
-            <a:extLst>
-              <a:ext uri="{FF2B5EF4-FFF2-40B4-BE49-F238E27FC236}">
-                <a16:creationId xmlns:a16="http://schemas.microsoft.com/office/drawing/2014/main" id="{2275EA5B-C8A9-EFC0-947D-62561998B2A8}"/>
-              </a:ext>
-            </a:extLst>
-          </p:cNvPr>
-          <p:cNvSpPr txBox="1"/>
-          <p:nvPr/>
-        </p:nvSpPr>
-        <p:spPr>
-          <a:xfrm>
-            <a:off x="14253880" y="30278083"/>
-            <a:ext cx="12824210" cy="646331"/>
-          </a:xfrm>
-          <a:prstGeom prst="rect">
-            <a:avLst/>
-          </a:prstGeom>
-          <a:solidFill>
-            <a:srgbClr val="005698"/>
-          </a:solidFill>
-        </p:spPr>
-        <p:txBody>
-          <a:bodyPr wrap="square" lIns="457200" anchor="ctr">
-            <a:spAutoFit/>
-          </a:bodyPr>
-          <a:lstStyle/>
-          <a:p>
-            <a:pPr>
-              <a:defRPr sz="3600" b="1">
-                <a:solidFill>
-                  <a:srgbClr val="004C99"/>
-                </a:solidFill>
-              </a:defRPr>
-            </a:pPr>
-            <a:r>
-              <a:rPr lang="en-US" dirty="0">
-                <a:solidFill>
-                  <a:srgbClr val="F7E8C9"/>
-                </a:solidFill>
-              </a:rPr>
-              <a:t>Authors</a:t>
-            </a:r>
-            <a:endParaRPr dirty="0">
-              <a:solidFill>
-                <a:srgbClr val="F7E8C9"/>
-              </a:solidFill>
-            </a:endParaRPr>
-          </a:p>
-        </p:txBody>
-      </p:sp>
-      <p:sp>
-        <p:nvSpPr>
-          <p:cNvPr id="45" name="TextBox 44">
-            <a:extLst>
-              <a:ext uri="{FF2B5EF4-FFF2-40B4-BE49-F238E27FC236}">
-                <a16:creationId xmlns:a16="http://schemas.microsoft.com/office/drawing/2014/main" id="{6D53E101-7345-4A95-4ABE-0F92745E7BAD}"/>
-              </a:ext>
-            </a:extLst>
-          </p:cNvPr>
-          <p:cNvSpPr txBox="1"/>
-          <p:nvPr/>
-        </p:nvSpPr>
-        <p:spPr>
-          <a:xfrm>
-            <a:off x="14253880" y="9657060"/>
-            <a:ext cx="12824210" cy="646331"/>
-          </a:xfrm>
-          <a:prstGeom prst="rect">
-            <a:avLst/>
-          </a:prstGeom>
-          <a:solidFill>
-            <a:srgbClr val="005698"/>
-          </a:solidFill>
-        </p:spPr>
-        <p:txBody>
-          <a:bodyPr wrap="square" lIns="457200" anchor="ctr">
-            <a:spAutoFit/>
-          </a:bodyPr>
-          <a:lstStyle/>
-          <a:p>
-            <a:pPr>
-              <a:defRPr sz="3600" b="1">
-                <a:solidFill>
-                  <a:srgbClr val="004C99"/>
-                </a:solidFill>
-              </a:defRPr>
-            </a:pPr>
-            <a:r>
-              <a:rPr lang="en-US" dirty="0">
-                <a:solidFill>
-                  <a:srgbClr val="F7E8C9"/>
-                </a:solidFill>
-              </a:rPr>
-              <a:t>Mentor Suggestions</a:t>
-            </a:r>
-            <a:endParaRPr dirty="0">
-              <a:solidFill>
-                <a:srgbClr val="F7E8C9"/>
-              </a:solidFill>
-            </a:endParaRPr>
-          </a:p>
-        </p:txBody>
-      </p:sp>
-      <p:sp>
-        <p:nvSpPr>
           <p:cNvPr id="46" name="TextBox 45">
             <a:extLst>
               <a:ext uri="{FF2B5EF4-FFF2-40B4-BE49-F238E27FC236}">
@@ -35200,6 +34215,521 @@
           </a:graphicData>
         </a:graphic>
       </p:graphicFrame>
+      <p:sp>
+        <p:nvSpPr>
+          <p:cNvPr id="10" name="TextBox 9">
+            <a:extLst>
+              <a:ext uri="{FF2B5EF4-FFF2-40B4-BE49-F238E27FC236}">
+                <a16:creationId xmlns:a16="http://schemas.microsoft.com/office/drawing/2014/main" id="{46DE835F-401C-1BEF-509B-821E28E83D80}"/>
+              </a:ext>
+            </a:extLst>
+          </p:cNvPr>
+          <p:cNvSpPr txBox="1"/>
+          <p:nvPr/>
+        </p:nvSpPr>
+        <p:spPr>
+          <a:xfrm>
+            <a:off x="353910" y="2686884"/>
+            <a:ext cx="12824210" cy="646331"/>
+          </a:xfrm>
+          <a:prstGeom prst="rect">
+            <a:avLst/>
+          </a:prstGeom>
+          <a:solidFill>
+            <a:srgbClr val="005698"/>
+          </a:solidFill>
+        </p:spPr>
+        <p:txBody>
+          <a:bodyPr wrap="square" lIns="457200" anchor="ctr">
+            <a:spAutoFit/>
+          </a:bodyPr>
+          <a:lstStyle/>
+          <a:p>
+            <a:pPr>
+              <a:defRPr sz="3600" b="1">
+                <a:solidFill>
+                  <a:srgbClr val="004C99"/>
+                </a:solidFill>
+              </a:defRPr>
+            </a:pPr>
+            <a:r>
+              <a:rPr lang="en-US" dirty="0">
+                <a:solidFill>
+                  <a:srgbClr val="F7E8C9"/>
+                </a:solidFill>
+              </a:rPr>
+              <a:t>Introduction</a:t>
+            </a:r>
+            <a:endParaRPr dirty="0">
+              <a:solidFill>
+                <a:srgbClr val="F7E8C9"/>
+              </a:solidFill>
+            </a:endParaRPr>
+          </a:p>
+        </p:txBody>
+      </p:sp>
+      <p:sp>
+        <p:nvSpPr>
+          <p:cNvPr id="11" name="TextBox 10">
+            <a:extLst>
+              <a:ext uri="{FF2B5EF4-FFF2-40B4-BE49-F238E27FC236}">
+                <a16:creationId xmlns:a16="http://schemas.microsoft.com/office/drawing/2014/main" id="{CCF02180-CCC5-4624-E890-866C9F011E8F}"/>
+              </a:ext>
+            </a:extLst>
+          </p:cNvPr>
+          <p:cNvSpPr txBox="1"/>
+          <p:nvPr/>
+        </p:nvSpPr>
+        <p:spPr>
+          <a:xfrm>
+            <a:off x="1353365" y="15028144"/>
+            <a:ext cx="11824752" cy="646331"/>
+          </a:xfrm>
+          <a:prstGeom prst="rect">
+            <a:avLst/>
+          </a:prstGeom>
+          <a:solidFill>
+            <a:schemeClr val="bg1"/>
+          </a:solidFill>
+          <a:ln w="12700">
+            <a:solidFill>
+              <a:srgbClr val="005698"/>
+            </a:solidFill>
+          </a:ln>
+        </p:spPr>
+        <p:txBody>
+          <a:bodyPr wrap="square" lIns="457200" anchor="ctr">
+            <a:spAutoFit/>
+          </a:bodyPr>
+          <a:lstStyle/>
+          <a:p>
+            <a:pPr>
+              <a:defRPr sz="3600" b="1">
+                <a:solidFill>
+                  <a:srgbClr val="004C99"/>
+                </a:solidFill>
+              </a:defRPr>
+            </a:pPr>
+            <a:r>
+              <a:rPr lang="en-US" dirty="0">
+                <a:solidFill>
+                  <a:srgbClr val="005698"/>
+                </a:solidFill>
+              </a:rPr>
+              <a:t>Goals</a:t>
+            </a:r>
+            <a:endParaRPr dirty="0">
+              <a:solidFill>
+                <a:srgbClr val="005698"/>
+              </a:solidFill>
+            </a:endParaRPr>
+          </a:p>
+        </p:txBody>
+      </p:sp>
+      <p:sp>
+        <p:nvSpPr>
+          <p:cNvPr id="12" name="TextBox 11">
+            <a:extLst>
+              <a:ext uri="{FF2B5EF4-FFF2-40B4-BE49-F238E27FC236}">
+                <a16:creationId xmlns:a16="http://schemas.microsoft.com/office/drawing/2014/main" id="{78C9E229-FD3F-6767-6729-C599BA6DDBC2}"/>
+              </a:ext>
+            </a:extLst>
+          </p:cNvPr>
+          <p:cNvSpPr txBox="1"/>
+          <p:nvPr/>
+        </p:nvSpPr>
+        <p:spPr>
+          <a:xfrm>
+            <a:off x="353909" y="24341062"/>
+            <a:ext cx="12824209" cy="646331"/>
+          </a:xfrm>
+          <a:prstGeom prst="rect">
+            <a:avLst/>
+          </a:prstGeom>
+          <a:solidFill>
+            <a:srgbClr val="005698"/>
+          </a:solidFill>
+        </p:spPr>
+        <p:txBody>
+          <a:bodyPr wrap="square" lIns="457200" anchor="ctr">
+            <a:spAutoFit/>
+          </a:bodyPr>
+          <a:lstStyle/>
+          <a:p>
+            <a:pPr>
+              <a:defRPr sz="3600" b="1">
+                <a:solidFill>
+                  <a:srgbClr val="004C99"/>
+                </a:solidFill>
+              </a:defRPr>
+            </a:pPr>
+            <a:r>
+              <a:rPr dirty="0">
+                <a:solidFill>
+                  <a:srgbClr val="F7E8C9"/>
+                </a:solidFill>
+              </a:rPr>
+              <a:t>Initial Course Syllabus</a:t>
+            </a:r>
+          </a:p>
+        </p:txBody>
+      </p:sp>
+      <p:sp>
+        <p:nvSpPr>
+          <p:cNvPr id="13" name="TextBox 12">
+            <a:extLst>
+              <a:ext uri="{FF2B5EF4-FFF2-40B4-BE49-F238E27FC236}">
+                <a16:creationId xmlns:a16="http://schemas.microsoft.com/office/drawing/2014/main" id="{173B2A26-BF54-31A4-FFE8-A81BE3F59062}"/>
+              </a:ext>
+            </a:extLst>
+          </p:cNvPr>
+          <p:cNvSpPr txBox="1"/>
+          <p:nvPr/>
+        </p:nvSpPr>
+        <p:spPr>
+          <a:xfrm>
+            <a:off x="14253881" y="2686884"/>
+            <a:ext cx="12824210" cy="646331"/>
+          </a:xfrm>
+          <a:prstGeom prst="rect">
+            <a:avLst/>
+          </a:prstGeom>
+          <a:solidFill>
+            <a:srgbClr val="005698"/>
+          </a:solidFill>
+        </p:spPr>
+        <p:txBody>
+          <a:bodyPr wrap="square" lIns="457200" anchor="ctr">
+            <a:spAutoFit/>
+          </a:bodyPr>
+          <a:lstStyle/>
+          <a:p>
+            <a:pPr>
+              <a:defRPr sz="3600" b="1">
+                <a:solidFill>
+                  <a:srgbClr val="004C99"/>
+                </a:solidFill>
+              </a:defRPr>
+            </a:pPr>
+            <a:r>
+              <a:rPr dirty="0">
+                <a:solidFill>
+                  <a:srgbClr val="F7E8C9"/>
+                </a:solidFill>
+              </a:rPr>
+              <a:t>Modified Course Syllabus</a:t>
+            </a:r>
+          </a:p>
+        </p:txBody>
+      </p:sp>
+      <p:sp>
+        <p:nvSpPr>
+          <p:cNvPr id="15" name="TextBox 14">
+            <a:extLst>
+              <a:ext uri="{FF2B5EF4-FFF2-40B4-BE49-F238E27FC236}">
+                <a16:creationId xmlns:a16="http://schemas.microsoft.com/office/drawing/2014/main" id="{4400DF90-D092-07B4-7F47-A928C4761502}"/>
+              </a:ext>
+            </a:extLst>
+          </p:cNvPr>
+          <p:cNvSpPr txBox="1"/>
+          <p:nvPr/>
+        </p:nvSpPr>
+        <p:spPr>
+          <a:xfrm>
+            <a:off x="14253880" y="13701905"/>
+            <a:ext cx="12824210" cy="646331"/>
+          </a:xfrm>
+          <a:prstGeom prst="rect">
+            <a:avLst/>
+          </a:prstGeom>
+          <a:solidFill>
+            <a:srgbClr val="005698"/>
+          </a:solidFill>
+        </p:spPr>
+        <p:txBody>
+          <a:bodyPr wrap="square" lIns="457200" anchor="ctr">
+            <a:spAutoFit/>
+          </a:bodyPr>
+          <a:lstStyle/>
+          <a:p>
+            <a:pPr>
+              <a:defRPr sz="3600" b="1">
+                <a:solidFill>
+                  <a:srgbClr val="004C99"/>
+                </a:solidFill>
+              </a:defRPr>
+            </a:pPr>
+            <a:r>
+              <a:rPr dirty="0">
+                <a:solidFill>
+                  <a:srgbClr val="F7E8C9"/>
+                </a:solidFill>
+              </a:rPr>
+              <a:t>Science Gateways Resources Used</a:t>
+            </a:r>
+          </a:p>
+        </p:txBody>
+      </p:sp>
+      <p:sp>
+        <p:nvSpPr>
+          <p:cNvPr id="16" name="TextBox 15">
+            <a:extLst>
+              <a:ext uri="{FF2B5EF4-FFF2-40B4-BE49-F238E27FC236}">
+                <a16:creationId xmlns:a16="http://schemas.microsoft.com/office/drawing/2014/main" id="{137EDB92-A781-2D59-6EA6-8B86CE388CA4}"/>
+              </a:ext>
+            </a:extLst>
+          </p:cNvPr>
+          <p:cNvSpPr txBox="1"/>
+          <p:nvPr/>
+        </p:nvSpPr>
+        <p:spPr>
+          <a:xfrm>
+            <a:off x="14253880" y="18235354"/>
+            <a:ext cx="12824210" cy="646331"/>
+          </a:xfrm>
+          <a:prstGeom prst="rect">
+            <a:avLst/>
+          </a:prstGeom>
+          <a:solidFill>
+            <a:srgbClr val="005698"/>
+          </a:solidFill>
+        </p:spPr>
+        <p:txBody>
+          <a:bodyPr wrap="square" lIns="457200" anchor="ctr">
+            <a:spAutoFit/>
+          </a:bodyPr>
+          <a:lstStyle/>
+          <a:p>
+            <a:pPr>
+              <a:defRPr sz="3600" b="1">
+                <a:solidFill>
+                  <a:srgbClr val="004C99"/>
+                </a:solidFill>
+              </a:defRPr>
+            </a:pPr>
+            <a:r>
+              <a:rPr lang="en-US" dirty="0">
+                <a:solidFill>
+                  <a:srgbClr val="F7E8C9"/>
+                </a:solidFill>
+              </a:rPr>
+              <a:t>Expansions</a:t>
+            </a:r>
+          </a:p>
+        </p:txBody>
+      </p:sp>
+      <p:sp>
+        <p:nvSpPr>
+          <p:cNvPr id="17" name="TextBox 16">
+            <a:extLst>
+              <a:ext uri="{FF2B5EF4-FFF2-40B4-BE49-F238E27FC236}">
+                <a16:creationId xmlns:a16="http://schemas.microsoft.com/office/drawing/2014/main" id="{74A98AF5-D675-1159-629F-49DB643D5D20}"/>
+              </a:ext>
+            </a:extLst>
+          </p:cNvPr>
+          <p:cNvSpPr txBox="1"/>
+          <p:nvPr/>
+        </p:nvSpPr>
+        <p:spPr>
+          <a:xfrm>
+            <a:off x="14253880" y="26009590"/>
+            <a:ext cx="12824210" cy="646331"/>
+          </a:xfrm>
+          <a:prstGeom prst="rect">
+            <a:avLst/>
+          </a:prstGeom>
+          <a:solidFill>
+            <a:srgbClr val="005698"/>
+          </a:solidFill>
+        </p:spPr>
+        <p:txBody>
+          <a:bodyPr wrap="square" lIns="457200" anchor="ctr">
+            <a:spAutoFit/>
+          </a:bodyPr>
+          <a:lstStyle/>
+          <a:p>
+            <a:pPr>
+              <a:defRPr sz="3600" b="1">
+                <a:solidFill>
+                  <a:srgbClr val="004C99"/>
+                </a:solidFill>
+              </a:defRPr>
+            </a:pPr>
+            <a:r>
+              <a:rPr dirty="0">
+                <a:solidFill>
+                  <a:srgbClr val="F7E8C9"/>
+                </a:solidFill>
+              </a:rPr>
+              <a:t>References</a:t>
+            </a:r>
+          </a:p>
+        </p:txBody>
+      </p:sp>
+      <p:sp>
+        <p:nvSpPr>
+          <p:cNvPr id="27" name="TextBox 26">
+            <a:extLst>
+              <a:ext uri="{FF2B5EF4-FFF2-40B4-BE49-F238E27FC236}">
+                <a16:creationId xmlns:a16="http://schemas.microsoft.com/office/drawing/2014/main" id="{62CB30D4-0C98-C729-815A-7BB59038A8E6}"/>
+              </a:ext>
+            </a:extLst>
+          </p:cNvPr>
+          <p:cNvSpPr txBox="1"/>
+          <p:nvPr/>
+        </p:nvSpPr>
+        <p:spPr>
+          <a:xfrm>
+            <a:off x="1353365" y="8411907"/>
+            <a:ext cx="11824751" cy="646331"/>
+          </a:xfrm>
+          <a:prstGeom prst="rect">
+            <a:avLst/>
+          </a:prstGeom>
+          <a:solidFill>
+            <a:schemeClr val="bg1"/>
+          </a:solidFill>
+          <a:ln w="12700">
+            <a:solidFill>
+              <a:srgbClr val="005698"/>
+            </a:solidFill>
+          </a:ln>
+        </p:spPr>
+        <p:txBody>
+          <a:bodyPr wrap="square" lIns="457200" anchor="ctr">
+            <a:spAutoFit/>
+          </a:bodyPr>
+          <a:lstStyle/>
+          <a:p>
+            <a:pPr>
+              <a:defRPr sz="3600" b="1">
+                <a:solidFill>
+                  <a:srgbClr val="004C99"/>
+                </a:solidFill>
+              </a:defRPr>
+            </a:pPr>
+            <a:r>
+              <a:rPr lang="en-US" dirty="0">
+                <a:solidFill>
+                  <a:srgbClr val="005698"/>
+                </a:solidFill>
+              </a:rPr>
+              <a:t>Target Course Description</a:t>
+            </a:r>
+            <a:endParaRPr dirty="0">
+              <a:solidFill>
+                <a:srgbClr val="005698"/>
+              </a:solidFill>
+            </a:endParaRPr>
+          </a:p>
+        </p:txBody>
+      </p:sp>
+      <p:sp>
+        <p:nvSpPr>
+          <p:cNvPr id="30" name="TextBox 29">
+            <a:extLst>
+              <a:ext uri="{FF2B5EF4-FFF2-40B4-BE49-F238E27FC236}">
+                <a16:creationId xmlns:a16="http://schemas.microsoft.com/office/drawing/2014/main" id="{CD237055-AF1D-EF68-68C1-EF687CED0E6B}"/>
+              </a:ext>
+            </a:extLst>
+          </p:cNvPr>
+          <p:cNvSpPr txBox="1"/>
+          <p:nvPr/>
+        </p:nvSpPr>
+        <p:spPr>
+          <a:xfrm>
+            <a:off x="14253880" y="30278083"/>
+            <a:ext cx="12824210" cy="646331"/>
+          </a:xfrm>
+          <a:prstGeom prst="rect">
+            <a:avLst/>
+          </a:prstGeom>
+          <a:solidFill>
+            <a:srgbClr val="005698"/>
+          </a:solidFill>
+        </p:spPr>
+        <p:txBody>
+          <a:bodyPr wrap="square" lIns="457200" anchor="ctr">
+            <a:spAutoFit/>
+          </a:bodyPr>
+          <a:lstStyle/>
+          <a:p>
+            <a:pPr>
+              <a:defRPr sz="3600" b="1">
+                <a:solidFill>
+                  <a:srgbClr val="004C99"/>
+                </a:solidFill>
+              </a:defRPr>
+            </a:pPr>
+            <a:r>
+              <a:rPr lang="en-US" dirty="0">
+                <a:solidFill>
+                  <a:srgbClr val="F7E8C9"/>
+                </a:solidFill>
+              </a:rPr>
+              <a:t>Authors</a:t>
+            </a:r>
+            <a:endParaRPr dirty="0">
+              <a:solidFill>
+                <a:srgbClr val="F7E8C9"/>
+              </a:solidFill>
+            </a:endParaRPr>
+          </a:p>
+        </p:txBody>
+      </p:sp>
+      <p:sp>
+        <p:nvSpPr>
+          <p:cNvPr id="31" name="TextBox 30">
+            <a:extLst>
+              <a:ext uri="{FF2B5EF4-FFF2-40B4-BE49-F238E27FC236}">
+                <a16:creationId xmlns:a16="http://schemas.microsoft.com/office/drawing/2014/main" id="{7ADD012C-EB20-4DD0-F520-49AB7DC351CB}"/>
+              </a:ext>
+            </a:extLst>
+          </p:cNvPr>
+          <p:cNvSpPr txBox="1"/>
+          <p:nvPr/>
+        </p:nvSpPr>
+        <p:spPr>
+          <a:xfrm>
+            <a:off x="14253880" y="9657060"/>
+            <a:ext cx="12824210" cy="646331"/>
+          </a:xfrm>
+          <a:prstGeom prst="rect">
+            <a:avLst/>
+          </a:prstGeom>
+          <a:solidFill>
+            <a:srgbClr val="005698"/>
+          </a:solidFill>
+        </p:spPr>
+        <p:txBody>
+          <a:bodyPr wrap="square" lIns="457200" anchor="ctr">
+            <a:spAutoFit/>
+          </a:bodyPr>
+          <a:lstStyle/>
+          <a:p>
+            <a:pPr>
+              <a:defRPr sz="3600" b="1">
+                <a:solidFill>
+                  <a:srgbClr val="004C99"/>
+                </a:solidFill>
+              </a:defRPr>
+            </a:pPr>
+            <a:r>
+              <a:rPr lang="en-US" dirty="0">
+                <a:solidFill>
+                  <a:srgbClr val="F7E8C9"/>
+                </a:solidFill>
+              </a:rPr>
+              <a:t>Mentor Suggestions</a:t>
+            </a:r>
+            <a:endParaRPr dirty="0">
+              <a:solidFill>
+                <a:srgbClr val="F7E8C9"/>
+              </a:solidFill>
+            </a:endParaRPr>
+          </a:p>
+        </p:txBody>
+      </p:sp>
     </p:spTree>
   </p:cSld>
   <p:clrMapOvr>

</xml_diff>